<commit_message>
Record successful real Zetaris analysis after Docker recovery
</commit_message>
<xml_diff>
--- a/submission/TalentLens-Deck.pptx
+++ b/submission/TalentLens-Deck.pptx
@@ -2,22 +2,22 @@
 <file path=ppt/presentation.xml><?xml version="1.0" encoding="utf-8"?>
 <p:presentation xmlns:p="http://schemas.openxmlformats.org/presentationml/2006/main">
   <p:sldMasterIdLst>
-    <p:sldMasterId xmlns:r="http://schemas.openxmlformats.org/officeDocument/2006/relationships" id="2147483648" r:id="R9ca01544cd5b4967"/>
+    <p:sldMasterId xmlns:r="http://schemas.openxmlformats.org/officeDocument/2006/relationships" id="2147483648" r:id="R748b838f81064a3b"/>
   </p:sldMasterIdLst>
   <p:notesMasterIdLst>
-    <p:notesMasterId xmlns:r="http://schemas.openxmlformats.org/officeDocument/2006/relationships" r:id="Re81621a971d84917"/>
+    <p:notesMasterId xmlns:r="http://schemas.openxmlformats.org/officeDocument/2006/relationships" r:id="R8ab0de4494334e81"/>
   </p:notesMasterIdLst>
   <p:sldIdLst>
-    <p:sldId xmlns:r="http://schemas.openxmlformats.org/officeDocument/2006/relationships" id="256" r:id="R081480e004ec426c"/>
-    <p:sldId xmlns:r="http://schemas.openxmlformats.org/officeDocument/2006/relationships" id="257" r:id="R8cf8fc34cad04915"/>
-    <p:sldId xmlns:r="http://schemas.openxmlformats.org/officeDocument/2006/relationships" id="258" r:id="Raff3488e92e84ba7"/>
-    <p:sldId xmlns:r="http://schemas.openxmlformats.org/officeDocument/2006/relationships" id="259" r:id="Re9b415d5e7dc41d6"/>
-    <p:sldId xmlns:r="http://schemas.openxmlformats.org/officeDocument/2006/relationships" id="260" r:id="Ra8149bc28ea34ad7"/>
-    <p:sldId xmlns:r="http://schemas.openxmlformats.org/officeDocument/2006/relationships" id="261" r:id="R3a3b9328503341a3"/>
-    <p:sldId xmlns:r="http://schemas.openxmlformats.org/officeDocument/2006/relationships" id="262" r:id="R002b7acdeffc43b7"/>
-    <p:sldId xmlns:r="http://schemas.openxmlformats.org/officeDocument/2006/relationships" id="263" r:id="R98736b8a4d2c4519"/>
-    <p:sldId xmlns:r="http://schemas.openxmlformats.org/officeDocument/2006/relationships" id="264" r:id="R544df8d7beb74eea"/>
-    <p:sldId xmlns:r="http://schemas.openxmlformats.org/officeDocument/2006/relationships" id="265" r:id="Rc73846b66ab24cda"/>
+    <p:sldId xmlns:r="http://schemas.openxmlformats.org/officeDocument/2006/relationships" id="256" r:id="Rd422e4eaf89c4efb"/>
+    <p:sldId xmlns:r="http://schemas.openxmlformats.org/officeDocument/2006/relationships" id="257" r:id="Rc702dfa1319e4e6d"/>
+    <p:sldId xmlns:r="http://schemas.openxmlformats.org/officeDocument/2006/relationships" id="258" r:id="R6e349f2b44c742cc"/>
+    <p:sldId xmlns:r="http://schemas.openxmlformats.org/officeDocument/2006/relationships" id="259" r:id="Rd3adbcefef1b490d"/>
+    <p:sldId xmlns:r="http://schemas.openxmlformats.org/officeDocument/2006/relationships" id="260" r:id="Rcdbe52b59b3f4dac"/>
+    <p:sldId xmlns:r="http://schemas.openxmlformats.org/officeDocument/2006/relationships" id="261" r:id="Re64d1399deb64e88"/>
+    <p:sldId xmlns:r="http://schemas.openxmlformats.org/officeDocument/2006/relationships" id="262" r:id="Rc653fd19a9004892"/>
+    <p:sldId xmlns:r="http://schemas.openxmlformats.org/officeDocument/2006/relationships" id="263" r:id="Rd950456bc33a4dcc"/>
+    <p:sldId xmlns:r="http://schemas.openxmlformats.org/officeDocument/2006/relationships" id="264" r:id="R5a534ccb722c47a5"/>
+    <p:sldId xmlns:r="http://schemas.openxmlformats.org/officeDocument/2006/relationships" id="265" r:id="R15efc53b2a134b03"/>
   </p:sldIdLst>
   <p:sldSz cx="12192000" cy="6858000"/>
   <p:notesSz cx="6858000" cy="9144000"/>
@@ -801,7 +801,7 @@
           <a:lstStyle xmlns:a="http://schemas.openxmlformats.org/drawingml/2006/main"/>
           <a:p xmlns:a="http://schemas.openxmlformats.org/drawingml/2006/main">
             <a:r>
-              <a:t>Sources: docs/SUBMISSION.md, examples/zetaris/verified-review-workflow.json. Model: nvidia/nemotron-3.5-lightning-30b-a3b. Official H-MEM conformance: 13/13 checks at pinned revision 1742dec56a66e58eef9dda2d2b865823758ca8cd. Cursor is optional and no Cursor-built award is claimed. The 27 October reinforcement queries before each Zetaris analysis and records provenance in the report and Markdown export. Query/request IDs are generated by TalentLens and sent to Zetaris for correlation, not independently signed receipts. Tests cover empty/failed reads, source replacement, deletion during query and local-mode independence. The 26 October recording predates this enhancement and is retained as historical evidence. Sources: docs/ZETARIS-WORKFLOW.md, tests/zetaris.test.js.</a:t>
+              <a:t>Sources: docs/SUBMISSION.md, examples/zetaris/verified-review-workflow.json. Model: nvidia/nemotron-3.5-lightning-30b-a3b. Official H-MEM conformance: 13/13 checks at pinned revision 1742dec56a66e58eef9dda2d2b865823758ca8cd. Cursor is optional and no Cursor-built award is claimed. The 27 October reinforcement queries before each Zetaris analysis and records provenance in the report and Markdown export. Query/request IDs are generated by TalentLens and sent to Zetaris for correlation, not independently signed receipts. Tests cover empty/failed reads, source replacement, deletion during query and local-mode independence. The 26 October recording predates this enhancement and is retained as historical evidence. Sources: docs/ZETARIS-WORKFLOW.md, tests/zetaris.test.js. Real fresh-query verification passed 27 October 2026 at 07:35 UTC: sourceMode zetaris, three fictional CVs, two requirements, three actual nvidia/nemotron-3.5-lightning-30b-a3b calls through Nightshift. Every call retained its receipt. The report preserves SQL, UTC timing, client query/request IDs and exact CV document versions/SHA-256. IDs are correlation identifiers, not independently signed receipts. Evidence: examples/zetaris/verified-fresh-query.json. Reproduce: npm run verify:zetaris. Docker recovered after preserving two stale socket directories; no images, containers or volumes were deleted. Recovery: docs/DOCKER-WINDOWS-RECOVERY.md. This single run is not a general accuracy or availability claim.</a:t>
             </a:r>
           </a:p>
         </p:txBody>
@@ -3524,12 +3524,12 @@
   </p:cSld>
   <p:clrMap bg1="lt1" tx1="dk1" bg2="lt2" tx2="dk2" accent1="accent1" accent2="accent2" accent3="accent3" accent4="accent4" accent5="accent5" accent6="accent6" hlink="hlink" folHlink="folHlink"/>
   <p:sldLayoutIdLst>
-    <p:sldLayoutId xmlns:r="http://schemas.openxmlformats.org/officeDocument/2006/relationships" id="2147483649" r:id="Re94a072cf4104e95"/>
-    <p:sldLayoutId xmlns:r="http://schemas.openxmlformats.org/officeDocument/2006/relationships" id="2147483650" r:id="R09f35050d34a4fcc"/>
-    <p:sldLayoutId xmlns:r="http://schemas.openxmlformats.org/officeDocument/2006/relationships" id="2147483651" r:id="R6f9507c624a8470f"/>
-    <p:sldLayoutId xmlns:r="http://schemas.openxmlformats.org/officeDocument/2006/relationships" id="2147483652" r:id="R2851993d0f764e7a"/>
-    <p:sldLayoutId xmlns:r="http://schemas.openxmlformats.org/officeDocument/2006/relationships" id="2147483653" r:id="Rd42367ca8e4d4fb5"/>
-    <p:sldLayoutId xmlns:r="http://schemas.openxmlformats.org/officeDocument/2006/relationships" id="2147483654" r:id="R46f04ddeb152405a"/>
+    <p:sldLayoutId xmlns:r="http://schemas.openxmlformats.org/officeDocument/2006/relationships" id="2147483649" r:id="R8fb3869bc3154e7b"/>
+    <p:sldLayoutId xmlns:r="http://schemas.openxmlformats.org/officeDocument/2006/relationships" id="2147483650" r:id="R67d8b0bd2e36473c"/>
+    <p:sldLayoutId xmlns:r="http://schemas.openxmlformats.org/officeDocument/2006/relationships" id="2147483651" r:id="R53231f3ed8c94a83"/>
+    <p:sldLayoutId xmlns:r="http://schemas.openxmlformats.org/officeDocument/2006/relationships" id="2147483652" r:id="R9af2942becf04b65"/>
+    <p:sldLayoutId xmlns:r="http://schemas.openxmlformats.org/officeDocument/2006/relationships" id="2147483653" r:id="Rad3b50a1b2ce40d6"/>
+    <p:sldLayoutId xmlns:r="http://schemas.openxmlformats.org/officeDocument/2006/relationships" id="2147483654" r:id="R5f80f73858334a61"/>
   </p:sldLayoutIdLst>
   <p:txStyles>
     <p:titleStyle>
@@ -4080,7 +4080,7 @@
           <p:cNvPr id="7" name="">
             <a:extLst xmlns:a="http://schemas.openxmlformats.org/drawingml/2006/main">
               <a:ext uri="{FF2B5EF4-FFF2-40B4-BE49-F238E27FC236}">
-                <a16:creationId xmlns:a16="http://schemas.microsoft.com/office/drawing/2014/main" id="{3AC2577B-C5CD-4F9E-883D-C77781C86430}"/>
+                <a16:creationId xmlns:a16="http://schemas.microsoft.com/office/drawing/2014/main" id="{2197BFB2-3A32-45BE-9B6B-A0C1F81295B8}"/>
               </a:ext>
             </a:extLst>
           </p:cNvPr>
@@ -4090,10 +4090,10 @@
           <p:nvPr/>
         </p:nvPicPr>
         <p:blipFill>
-          <a:blip xmlns:r="http://schemas.openxmlformats.org/officeDocument/2006/relationships" xmlns:a="http://schemas.openxmlformats.org/drawingml/2006/main" r:embed="R043c5350be534083">
+          <a:blip xmlns:r="http://schemas.openxmlformats.org/officeDocument/2006/relationships" xmlns:a="http://schemas.openxmlformats.org/drawingml/2006/main" r:embed="R6e25eed5e59946af">
             <a:extLst>
               <a:ext uri="{96DAC541-7B7A-43D3-8B79-37D633B846F1}">
-                <asvg:svgBlip xmlns:asvg="http://schemas.microsoft.com/office/drawing/2016/SVG/main" r:embed="R94bcab64d6fe4810"/>
+                <asvg:svgBlip xmlns:asvg="http://schemas.microsoft.com/office/drawing/2016/SVG/main" r:embed="Rbcf7385dd7aa40e4"/>
               </a:ext>
             </a:extLst>
           </a:blip>
@@ -8691,7 +8691,7 @@
           <p:cNvPr id="8" name="">
             <a:extLst xmlns:a="http://schemas.openxmlformats.org/drawingml/2006/main">
               <a:ext uri="{FF2B5EF4-FFF2-40B4-BE49-F238E27FC236}">
-                <a16:creationId xmlns:a16="http://schemas.microsoft.com/office/drawing/2014/main" id="{56912F0F-4042-4D94-B68B-F13B9AEDC46D}"/>
+                <a16:creationId xmlns:a16="http://schemas.microsoft.com/office/drawing/2014/main" id="{020F70D0-AA7C-499C-A106-C0B9D0FE32E2}"/>
               </a:ext>
             </a:extLst>
           </p:cNvPr>
@@ -8701,7 +8701,7 @@
           <p:nvPr/>
         </p:nvPicPr>
         <p:blipFill>
-          <a:blip xmlns:r="http://schemas.openxmlformats.org/officeDocument/2006/relationships" xmlns:a="http://schemas.openxmlformats.org/drawingml/2006/main" r:embed="R5873538696cf46d3"/>
+          <a:blip xmlns:r="http://schemas.openxmlformats.org/officeDocument/2006/relationships" xmlns:a="http://schemas.openxmlformats.org/drawingml/2006/main" r:embed="Re8eebc929d4a4c4e"/>
           <a:stretch xmlns:a="http://schemas.openxmlformats.org/drawingml/2006/main"/>
         </p:blipFill>
         <p:spPr>
@@ -8914,7 +8914,7 @@
           <p:cNvPr id="43" name="">
             <a:extLst xmlns:a="http://schemas.openxmlformats.org/drawingml/2006/main">
               <a:ext uri="{FF2B5EF4-FFF2-40B4-BE49-F238E27FC236}">
-                <a16:creationId xmlns:a16="http://schemas.microsoft.com/office/drawing/2014/main" id="{D101EEF9-55CA-4B7C-A615-562D286832EC}"/>
+                <a16:creationId xmlns:a16="http://schemas.microsoft.com/office/drawing/2014/main" id="{30F2E62B-5E6A-4DD4-8A74-8353F663D2C5}"/>
               </a:ext>
             </a:extLst>
           </p:cNvPr>
@@ -8945,7 +8945,7 @@
           <p:cNvPr id="42" name="">
             <a:extLst xmlns:a="http://schemas.openxmlformats.org/drawingml/2006/main">
               <a:ext uri="{FF2B5EF4-FFF2-40B4-BE49-F238E27FC236}">
-                <a16:creationId xmlns:a16="http://schemas.microsoft.com/office/drawing/2014/main" id="{82FA5692-EDA4-4F16-AD19-FAA9D2ED11F9}"/>
+                <a16:creationId xmlns:a16="http://schemas.microsoft.com/office/drawing/2014/main" id="{6BCBD678-9983-4ADE-A529-C5F6A5CD355F}"/>
               </a:ext>
             </a:extLst>
           </p:cNvPr>
@@ -8980,7 +8980,7 @@
           <p:cNvPr id="39" name="">
             <a:extLst xmlns:a="http://schemas.openxmlformats.org/drawingml/2006/main">
               <a:ext uri="{FF2B5EF4-FFF2-40B4-BE49-F238E27FC236}">
-                <a16:creationId xmlns:a16="http://schemas.microsoft.com/office/drawing/2014/main" id="{AFE82E24-01B2-4C21-A6BD-93B7CC9EE89A}"/>
+                <a16:creationId xmlns:a16="http://schemas.microsoft.com/office/drawing/2014/main" id="{BF421F64-A9E4-4380-9915-5EB3A308DA7F}"/>
               </a:ext>
             </a:extLst>
           </p:cNvPr>
@@ -9011,7 +9011,7 @@
           <p:cNvPr id="38" name="">
             <a:extLst xmlns:a="http://schemas.openxmlformats.org/drawingml/2006/main">
               <a:ext uri="{FF2B5EF4-FFF2-40B4-BE49-F238E27FC236}">
-                <a16:creationId xmlns:a16="http://schemas.microsoft.com/office/drawing/2014/main" id="{DF2BF020-477F-4709-95F7-3EBF28441727}"/>
+                <a16:creationId xmlns:a16="http://schemas.microsoft.com/office/drawing/2014/main" id="{4EFAD026-CD36-4C5D-A87D-AA7AF4E517C9}"/>
               </a:ext>
             </a:extLst>
           </p:cNvPr>
@@ -9042,7 +9042,7 @@
           <p:cNvPr id="37" name="">
             <a:extLst xmlns:a="http://schemas.openxmlformats.org/drawingml/2006/main">
               <a:ext uri="{FF2B5EF4-FFF2-40B4-BE49-F238E27FC236}">
-                <a16:creationId xmlns:a16="http://schemas.microsoft.com/office/drawing/2014/main" id="{AF246F15-34CB-4EC1-8382-547A2434A3F1}"/>
+                <a16:creationId xmlns:a16="http://schemas.microsoft.com/office/drawing/2014/main" id="{64E3C409-C54E-4FDD-B0CA-9AF4D6891E2A}"/>
               </a:ext>
             </a:extLst>
           </p:cNvPr>
@@ -9073,7 +9073,7 @@
           <p:cNvPr id="36" name="">
             <a:extLst xmlns:a="http://schemas.openxmlformats.org/drawingml/2006/main">
               <a:ext uri="{FF2B5EF4-FFF2-40B4-BE49-F238E27FC236}">
-                <a16:creationId xmlns:a16="http://schemas.microsoft.com/office/drawing/2014/main" id="{6BFB0627-F524-4608-AB9B-310D3E6BAEE7}"/>
+                <a16:creationId xmlns:a16="http://schemas.microsoft.com/office/drawing/2014/main" id="{E7C96836-0ADE-42D0-930F-D20DD1F9E0E3}"/>
               </a:ext>
             </a:extLst>
           </p:cNvPr>
@@ -12803,7 +12803,7 @@
                 <a:ea typeface="Segoe UI"/>
                 <a:cs typeface="Segoe UI"/>
               </a:rPr>
-              <a:t>Joins profile and CV sources. Fresh SELECT before analysis, with a visible query and document trace.</a:t>
+              <a:t>Joined profile/CV view. Three-CV live run verified with a fresh query and exact document traces.</a:t>
             </a:r>
           </a:p>
         </p:txBody>

</xml_diff>